<commit_message>
feat: Add full custom template support for tournament flow with manual decision dialogs for special cases
</commit_message>
<xml_diff>
--- a/public/templates/template.pptx
+++ b/public/templates/template.pptx
@@ -379,7 +379,7 @@
           <a:p>
             <a:fld id="{8C90509D-92FA-4939-A039-A3479FC21D0B}" type="datetimeFigureOut">
               <a:rPr lang="de-DE" smtClean="0"/>
-              <a:t>06.01.2026</a:t>
+              <a:t>29.10.2026</a:t>
             </a:fld>
             <a:endParaRPr lang="de-DE"/>
           </a:p>
@@ -433,7 +433,7 @@
           <a:p>
             <a:fld id="{49BBBD81-C55C-424B-A944-5C8BA9DA261A}" type="slidenum">
               <a:rPr lang="de-DE" smtClean="0"/>
-              <a:t>‹#›</a:t>
+              <a:t>‹Nr.›</a:t>
             </a:fld>
             <a:endParaRPr lang="de-DE"/>
           </a:p>
@@ -577,7 +577,7 @@
           <a:p>
             <a:fld id="{8C90509D-92FA-4939-A039-A3479FC21D0B}" type="datetimeFigureOut">
               <a:rPr lang="de-DE" smtClean="0"/>
-              <a:t>06.01.2026</a:t>
+              <a:t>29.10.2026</a:t>
             </a:fld>
             <a:endParaRPr lang="de-DE"/>
           </a:p>
@@ -631,7 +631,7 @@
           <a:p>
             <a:fld id="{49BBBD81-C55C-424B-A944-5C8BA9DA261A}" type="slidenum">
               <a:rPr lang="de-DE" smtClean="0"/>
-              <a:t>‹#›</a:t>
+              <a:t>‹Nr.›</a:t>
             </a:fld>
             <a:endParaRPr lang="de-DE"/>
           </a:p>
@@ -785,7 +785,7 @@
           <a:p>
             <a:fld id="{8C90509D-92FA-4939-A039-A3479FC21D0B}" type="datetimeFigureOut">
               <a:rPr lang="de-DE" smtClean="0"/>
-              <a:t>06.01.2026</a:t>
+              <a:t>29.10.2026</a:t>
             </a:fld>
             <a:endParaRPr lang="de-DE"/>
           </a:p>
@@ -839,7 +839,7 @@
           <a:p>
             <a:fld id="{49BBBD81-C55C-424B-A944-5C8BA9DA261A}" type="slidenum">
               <a:rPr lang="de-DE" smtClean="0"/>
-              <a:t>‹#›</a:t>
+              <a:t>‹Nr.›</a:t>
             </a:fld>
             <a:endParaRPr lang="de-DE"/>
           </a:p>
@@ -983,7 +983,7 @@
           <a:p>
             <a:fld id="{8C90509D-92FA-4939-A039-A3479FC21D0B}" type="datetimeFigureOut">
               <a:rPr lang="de-DE" smtClean="0"/>
-              <a:t>06.01.2026</a:t>
+              <a:t>29.10.2026</a:t>
             </a:fld>
             <a:endParaRPr lang="de-DE"/>
           </a:p>
@@ -1037,7 +1037,7 @@
           <a:p>
             <a:fld id="{49BBBD81-C55C-424B-A944-5C8BA9DA261A}" type="slidenum">
               <a:rPr lang="de-DE" smtClean="0"/>
-              <a:t>‹#›</a:t>
+              <a:t>‹Nr.›</a:t>
             </a:fld>
             <a:endParaRPr lang="de-DE"/>
           </a:p>
@@ -1258,7 +1258,7 @@
           <a:p>
             <a:fld id="{8C90509D-92FA-4939-A039-A3479FC21D0B}" type="datetimeFigureOut">
               <a:rPr lang="de-DE" smtClean="0"/>
-              <a:t>06.01.2026</a:t>
+              <a:t>29.10.2026</a:t>
             </a:fld>
             <a:endParaRPr lang="de-DE"/>
           </a:p>
@@ -1312,7 +1312,7 @@
           <a:p>
             <a:fld id="{49BBBD81-C55C-424B-A944-5C8BA9DA261A}" type="slidenum">
               <a:rPr lang="de-DE" smtClean="0"/>
-              <a:t>‹#›</a:t>
+              <a:t>‹Nr.›</a:t>
             </a:fld>
             <a:endParaRPr lang="de-DE"/>
           </a:p>
@@ -1523,7 +1523,7 @@
           <a:p>
             <a:fld id="{8C90509D-92FA-4939-A039-A3479FC21D0B}" type="datetimeFigureOut">
               <a:rPr lang="de-DE" smtClean="0"/>
-              <a:t>06.01.2026</a:t>
+              <a:t>29.10.2026</a:t>
             </a:fld>
             <a:endParaRPr lang="de-DE"/>
           </a:p>
@@ -1577,7 +1577,7 @@
           <a:p>
             <a:fld id="{49BBBD81-C55C-424B-A944-5C8BA9DA261A}" type="slidenum">
               <a:rPr lang="de-DE" smtClean="0"/>
-              <a:t>‹#›</a:t>
+              <a:t>‹Nr.›</a:t>
             </a:fld>
             <a:endParaRPr lang="de-DE"/>
           </a:p>
@@ -1935,7 +1935,7 @@
           <a:p>
             <a:fld id="{8C90509D-92FA-4939-A039-A3479FC21D0B}" type="datetimeFigureOut">
               <a:rPr lang="de-DE" smtClean="0"/>
-              <a:t>06.01.2026</a:t>
+              <a:t>29.10.2026</a:t>
             </a:fld>
             <a:endParaRPr lang="de-DE"/>
           </a:p>
@@ -1989,7 +1989,7 @@
           <a:p>
             <a:fld id="{49BBBD81-C55C-424B-A944-5C8BA9DA261A}" type="slidenum">
               <a:rPr lang="de-DE" smtClean="0"/>
-              <a:t>‹#›</a:t>
+              <a:t>‹Nr.›</a:t>
             </a:fld>
             <a:endParaRPr lang="de-DE"/>
           </a:p>
@@ -2076,7 +2076,7 @@
           <a:p>
             <a:fld id="{8C90509D-92FA-4939-A039-A3479FC21D0B}" type="datetimeFigureOut">
               <a:rPr lang="de-DE" smtClean="0"/>
-              <a:t>06.01.2026</a:t>
+              <a:t>29.10.2026</a:t>
             </a:fld>
             <a:endParaRPr lang="de-DE"/>
           </a:p>
@@ -2130,7 +2130,7 @@
           <a:p>
             <a:fld id="{49BBBD81-C55C-424B-A944-5C8BA9DA261A}" type="slidenum">
               <a:rPr lang="de-DE" smtClean="0"/>
-              <a:t>‹#›</a:t>
+              <a:t>‹Nr.›</a:t>
             </a:fld>
             <a:endParaRPr lang="de-DE"/>
           </a:p>
@@ -2189,7 +2189,7 @@
           <a:p>
             <a:fld id="{8C90509D-92FA-4939-A039-A3479FC21D0B}" type="datetimeFigureOut">
               <a:rPr lang="de-DE" smtClean="0"/>
-              <a:t>06.01.2026</a:t>
+              <a:t>29.10.2026</a:t>
             </a:fld>
             <a:endParaRPr lang="de-DE"/>
           </a:p>
@@ -2243,7 +2243,7 @@
           <a:p>
             <a:fld id="{49BBBD81-C55C-424B-A944-5C8BA9DA261A}" type="slidenum">
               <a:rPr lang="de-DE" smtClean="0"/>
-              <a:t>‹#›</a:t>
+              <a:t>‹Nr.›</a:t>
             </a:fld>
             <a:endParaRPr lang="de-DE"/>
           </a:p>
@@ -2500,7 +2500,7 @@
           <a:p>
             <a:fld id="{8C90509D-92FA-4939-A039-A3479FC21D0B}" type="datetimeFigureOut">
               <a:rPr lang="de-DE" smtClean="0"/>
-              <a:t>06.01.2026</a:t>
+              <a:t>29.10.2026</a:t>
             </a:fld>
             <a:endParaRPr lang="de-DE"/>
           </a:p>
@@ -2554,7 +2554,7 @@
           <a:p>
             <a:fld id="{49BBBD81-C55C-424B-A944-5C8BA9DA261A}" type="slidenum">
               <a:rPr lang="de-DE" smtClean="0"/>
-              <a:t>‹#›</a:t>
+              <a:t>‹Nr.›</a:t>
             </a:fld>
             <a:endParaRPr lang="de-DE"/>
           </a:p>
@@ -2788,7 +2788,7 @@
           <a:p>
             <a:fld id="{8C90509D-92FA-4939-A039-A3479FC21D0B}" type="datetimeFigureOut">
               <a:rPr lang="de-DE" smtClean="0"/>
-              <a:t>06.01.2026</a:t>
+              <a:t>29.10.2026</a:t>
             </a:fld>
             <a:endParaRPr lang="de-DE"/>
           </a:p>
@@ -2842,7 +2842,7 @@
           <a:p>
             <a:fld id="{49BBBD81-C55C-424B-A944-5C8BA9DA261A}" type="slidenum">
               <a:rPr lang="de-DE" smtClean="0"/>
-              <a:t>‹#›</a:t>
+              <a:t>‹Nr.›</a:t>
             </a:fld>
             <a:endParaRPr lang="de-DE"/>
           </a:p>
@@ -3029,7 +3029,7 @@
           <a:p>
             <a:fld id="{8C90509D-92FA-4939-A039-A3479FC21D0B}" type="datetimeFigureOut">
               <a:rPr lang="de-DE" smtClean="0"/>
-              <a:t>06.01.2026</a:t>
+              <a:t>29.10.2026</a:t>
             </a:fld>
             <a:endParaRPr lang="de-DE"/>
           </a:p>
@@ -3119,7 +3119,7 @@
           <a:p>
             <a:fld id="{49BBBD81-C55C-424B-A944-5C8BA9DA261A}" type="slidenum">
               <a:rPr lang="de-DE" smtClean="0"/>
-              <a:t>‹#›</a:t>
+              <a:t>‹Nr.›</a:t>
             </a:fld>
             <a:endParaRPr lang="de-DE"/>
           </a:p>
@@ -3837,97 +3837,106 @@
           <a:lstStyle/>
           <a:p>
             <a:r>
+              <a:rPr lang="de-DE" dirty="0">
+                <a:ea typeface="Calibri"/>
+                <a:cs typeface="Calibri"/>
+              </a:rPr>
+              <a:t>SV Sulmetingen (Equipment)</a:t>
+            </a:r>
+          </a:p>
+          <a:p>
+            <a:r>
+              <a:rPr lang="de-DE" dirty="0">
+                <a:ea typeface="Calibri"/>
+                <a:cs typeface="Calibri"/>
+              </a:rPr>
+              <a:t>Schiedsrichter</a:t>
+            </a:r>
+          </a:p>
+          <a:p>
+            <a:r>
               <a:rPr lang="de-DE">
                 <a:ea typeface="Calibri"/>
                 <a:cs typeface="Calibri"/>
               </a:rPr>
-              <a:t>SV Sulmetingen (Equipment)</a:t>
-            </a:r>
-          </a:p>
-          <a:p>
-            <a:r>
-              <a:rPr lang="de-DE">
-                <a:ea typeface="Calibri"/>
-                <a:cs typeface="Calibri"/>
-              </a:rPr>
-              <a:t>Schiedsrichter</a:t>
-            </a:r>
-          </a:p>
-          <a:p>
-            <a:r>
-              <a:rPr lang="de-DE"/>
+              <a:t>Ulli</a:t>
+            </a:r>
+          </a:p>
+          <a:p>
+            <a:r>
+              <a:rPr lang="de-DE" dirty="0"/>
               <a:t>Marc </a:t>
             </a:r>
             <a:r>
-              <a:rPr lang="de-DE" err="1"/>
+              <a:rPr lang="de-DE" dirty="0" err="1"/>
               <a:t>Gretzinger</a:t>
             </a:r>
             <a:r>
-              <a:rPr lang="de-DE"/>
+              <a:rPr lang="de-DE" dirty="0"/>
               <a:t> (Technik)</a:t>
             </a:r>
           </a:p>
           <a:p>
             <a:r>
-              <a:rPr lang="en-US" err="1"/>
+              <a:rPr lang="en-US" dirty="0" err="1"/>
               <a:t>Unsere</a:t>
             </a:r>
             <a:r>
-              <a:rPr lang="en-US"/>
+              <a:rPr lang="en-US" dirty="0"/>
               <a:t> </a:t>
             </a:r>
             <a:r>
-              <a:rPr lang="en-US" err="1"/>
+              <a:rPr lang="en-US" dirty="0" err="1"/>
               <a:t>Mädels</a:t>
             </a:r>
             <a:r>
-              <a:rPr lang="en-US"/>
+              <a:rPr lang="en-US" dirty="0"/>
               <a:t> (</a:t>
             </a:r>
             <a:r>
-              <a:rPr lang="en-US" err="1"/>
+              <a:rPr lang="en-US" dirty="0" err="1"/>
               <a:t>Küche</a:t>
             </a:r>
             <a:r>
-              <a:rPr lang="en-US"/>
+              <a:rPr lang="en-US" dirty="0"/>
               <a:t> &amp; Bar) </a:t>
             </a:r>
-            <a:endParaRPr lang="en-US">
+            <a:endParaRPr lang="en-US" dirty="0">
               <a:ea typeface="Calibri"/>
               <a:cs typeface="Calibri"/>
             </a:endParaRPr>
           </a:p>
           <a:p>
             <a:r>
-              <a:rPr lang="en-US">
+              <a:rPr lang="en-US" dirty="0">
                 <a:ea typeface="Calibri"/>
                 <a:cs typeface="Calibri"/>
               </a:rPr>
               <a:t>Alle </a:t>
             </a:r>
             <a:r>
-              <a:rPr lang="en-US" err="1">
+              <a:rPr lang="en-US" dirty="0" err="1">
                 <a:ea typeface="Calibri" panose="020F0502020204030204"/>
                 <a:cs typeface="Calibri" panose="020F0502020204030204"/>
               </a:rPr>
               <a:t>Zuschauer</a:t>
             </a:r>
             <a:r>
-              <a:rPr lang="en-US">
+              <a:rPr lang="en-US" dirty="0">
                 <a:ea typeface="Calibri" panose="020F0502020204030204"/>
                 <a:cs typeface="Calibri" panose="020F0502020204030204"/>
               </a:rPr>
               <a:t> &amp; Fans für die </a:t>
             </a:r>
             <a:r>
-              <a:rPr lang="en-US" err="1">
+              <a:rPr lang="en-US" dirty="0" err="1">
                 <a:ea typeface="Calibri" panose="020F0502020204030204"/>
                 <a:cs typeface="Calibri" panose="020F0502020204030204"/>
               </a:rPr>
               <a:t>tolle</a:t>
             </a:r>
             <a:r>
-              <a:rPr lang="en-US">
+              <a:rPr lang="en-US" dirty="0">
                 <a:ea typeface="Calibri" panose="020F0502020204030204"/>
                 <a:cs typeface="Calibri" panose="020F0502020204030204"/>
               </a:rPr>
@@ -3938,13 +3947,13 @@
             <a:pPr marL="0" indent="0">
               <a:buNone/>
             </a:pPr>
-            <a:endParaRPr lang="en-US">
+            <a:endParaRPr lang="en-US" dirty="0">
               <a:ea typeface="Calibri" panose="020F0502020204030204"/>
               <a:cs typeface="Calibri" panose="020F0502020204030204"/>
             </a:endParaRPr>
           </a:p>
           <a:p>
-            <a:endParaRPr lang="de-DE"/>
+            <a:endParaRPr lang="de-DE" dirty="0"/>
           </a:p>
         </p:txBody>
       </p:sp>

</xml_diff>